<commit_message>
Publish current BFM teaser v4.1 deck assets
</commit_message>
<xml_diff>
--- a/artifacts/bfm-video-current/bfm-teaser-90s.pptx
+++ b/artifacts/bfm-video-current/bfm-teaser-90s.pptx
@@ -2587,7 +2587,7 @@
       </p:sp>
       <p:pic>
         <p:nvPicPr>
-          <p:cNvPr id="7" name="Image 0" descr="C:\Users\lukoe\Downloads\asn-reports\artifacts\bfm-video-redesign-v4-2026-06-09-1247\_crops\03-gateway-up.png">    </p:cNvPr>
+          <p:cNvPr id="7" name="Image 0" descr="C:\Users\lukoe\Downloads\asn-reports\artifacts\bfm-video-v41-2026-06-09-1322\_crops\03-gateway-up.png">    </p:cNvPr>
           <p:cNvPicPr>
             <a:picLocks noChangeAspect="1"/>
           </p:cNvPicPr>
@@ -2869,8 +2869,8 @@
         </p:nvSpPr>
         <p:spPr>
           <a:xfrm>
-            <a:off x="283464" y="2295144"/>
-            <a:ext cx="11594592" cy="2039112"/>
+            <a:off x="1234440" y="1874520"/>
+            <a:ext cx="9738360" cy="3977640"/>
           </a:xfrm>
           <a:prstGeom prst="roundRect">
             <a:avLst/>
@@ -2878,7 +2878,7 @@
           <a:solidFill>
             <a:srgbClr val="FFFFFF"/>
           </a:solidFill>
-          <a:ln w="12700">
+          <a:ln w="19050">
             <a:solidFill>
               <a:srgbClr val="4D7DF3"/>
             </a:solidFill>
@@ -2886,39 +2886,95 @@
           </a:ln>
         </p:spPr>
       </p:sp>
-      <p:pic>
-        <p:nvPicPr>
-          <p:cNvPr id="7" name="Image 0" descr="C:\Users\lukoe\Downloads\asn-reports\artifacts\bfm-video-redesign-v4-2026-06-09-1247\_crops\04-heading-up.png">    </p:cNvPr>
-          <p:cNvPicPr>
-            <a:picLocks noChangeAspect="1"/>
-          </p:cNvPicPr>
-          <p:nvPr/>
-        </p:nvPicPr>
-        <p:blipFill>
-          <a:blip r:embed="rId1"/>
-          <a:srcRect l="0" r="0" t="0" b="0"/>
-          <a:stretch/>
-        </p:blipFill>
-        <p:spPr>
-          <a:xfrm>
-            <a:off x="320040" y="2331720"/>
-            <a:ext cx="11521440" cy="1965960"/>
-          </a:xfrm>
-          <a:prstGeom prst="rect">
-            <a:avLst/>
-          </a:prstGeom>
-        </p:spPr>
-      </p:pic>
-      <p:sp>
-        <p:nvSpPr>
-          <p:cNvPr id="8" name="Shape 5"/>
-          <p:cNvSpPr/>
-          <p:nvPr/>
-        </p:nvSpPr>
-        <p:spPr>
-          <a:xfrm>
-            <a:off x="502920" y="4617720"/>
-            <a:ext cx="4754880" cy="457200"/>
+      <p:sp>
+        <p:nvSpPr>
+          <p:cNvPr id="7" name="Shape 5"/>
+          <p:cNvSpPr/>
+          <p:nvPr/>
+        </p:nvSpPr>
+        <p:spPr>
+          <a:xfrm>
+            <a:off x="1645920" y="2258568"/>
+            <a:ext cx="777240" cy="36576"/>
+          </a:xfrm>
+          <a:prstGeom prst="rect">
+            <a:avLst/>
+          </a:prstGeom>
+          <a:solidFill>
+            <a:srgbClr val="D4AF37"/>
+          </a:solidFill>
+          <a:ln/>
+        </p:spPr>
+      </p:sp>
+      <p:sp>
+        <p:nvSpPr>
+          <p:cNvPr id="8" name="Text 6"/>
+          <p:cNvSpPr/>
+          <p:nvPr/>
+        </p:nvSpPr>
+        <p:spPr>
+          <a:xfrm>
+            <a:off x="1645920" y="2441448"/>
+            <a:ext cx="8915400" cy="868680"/>
+          </a:xfrm>
+          <a:prstGeom prst="rect">
+            <a:avLst/>
+          </a:prstGeom>
+          <a:noFill/>
+          <a:ln/>
+        </p:spPr>
+        <p:txBody>
+          <a:bodyPr wrap="square" rtlCol="0" anchor="ctr"/>
+          <a:lstStyle/>
+          <a:p>
+            <a:pPr algn="ctr" indent="0" marL="0">
+              <a:buNone/>
+            </a:pPr>
+            <a:r>
+              <a:rPr lang="en-US" sz="2600" b="1" dirty="0">
+                <a:solidFill>
+                  <a:srgbClr val="0B1D3A"/>
+                </a:solidFill>
+                <a:latin typeface="Playfair Display" pitchFamily="34" charset="0"/>
+                <a:ea typeface="Playfair Display" pitchFamily="34" charset="-122"/>
+                <a:cs typeface="Playfair Display" pitchFamily="34" charset="-120"/>
+              </a:rPr>
+              <a:t>3. PERSONAL OBSERVATIONS OF THE RELATIONSHIP</a:t>
+            </a:r>
+            <a:endParaRPr lang="en-US" sz="2600" dirty="0"/>
+          </a:p>
+        </p:txBody>
+      </p:sp>
+      <p:sp>
+        <p:nvSpPr>
+          <p:cNvPr id="9" name="Shape 7"/>
+          <p:cNvSpPr/>
+          <p:nvPr/>
+        </p:nvSpPr>
+        <p:spPr>
+          <a:xfrm>
+            <a:off x="1737360" y="3474720"/>
+            <a:ext cx="8732520" cy="54864"/>
+          </a:xfrm>
+          <a:prstGeom prst="rect">
+            <a:avLst/>
+          </a:prstGeom>
+          <a:solidFill>
+            <a:srgbClr val="E6F0FA"/>
+          </a:solidFill>
+          <a:ln/>
+        </p:spPr>
+      </p:sp>
+      <p:sp>
+        <p:nvSpPr>
+          <p:cNvPr id="10" name="Shape 8"/>
+          <p:cNvSpPr/>
+          <p:nvPr/>
+        </p:nvSpPr>
+        <p:spPr>
+          <a:xfrm>
+            <a:off x="2286000" y="3840480"/>
+            <a:ext cx="7635240" cy="530352"/>
           </a:xfrm>
           <a:prstGeom prst="roundRect">
             <a:avLst/>
@@ -2926,7 +2982,7 @@
           <a:solidFill>
             <a:srgbClr val="E6F0FA"/>
           </a:solidFill>
-          <a:ln w="15875">
+          <a:ln w="12700">
             <a:solidFill>
               <a:srgbClr val="D4AF37"/>
             </a:solidFill>
@@ -2936,14 +2992,34 @@
       </p:sp>
       <p:sp>
         <p:nvSpPr>
-          <p:cNvPr id="9" name="Text 6"/>
-          <p:cNvSpPr/>
-          <p:nvPr/>
-        </p:nvSpPr>
-        <p:spPr>
-          <a:xfrm>
-            <a:off x="612648" y="4709160"/>
-            <a:ext cx="4535424" cy="292608"/>
+          <p:cNvPr id="11" name="Shape 9"/>
+          <p:cNvSpPr/>
+          <p:nvPr/>
+        </p:nvSpPr>
+        <p:spPr>
+          <a:xfrm>
+            <a:off x="2468880" y="4023360"/>
+            <a:ext cx="164592" cy="164592"/>
+          </a:xfrm>
+          <a:prstGeom prst="ellipse">
+            <a:avLst/>
+          </a:prstGeom>
+          <a:solidFill>
+            <a:srgbClr val="4D7DF3"/>
+          </a:solidFill>
+          <a:ln/>
+        </p:spPr>
+      </p:sp>
+      <p:sp>
+        <p:nvSpPr>
+          <p:cNvPr id="12" name="Text 10"/>
+          <p:cNvSpPr/>
+          <p:nvPr/>
+        </p:nvSpPr>
+        <p:spPr>
+          <a:xfrm>
+            <a:off x="2743200" y="3968496"/>
+            <a:ext cx="7086600" cy="292608"/>
           </a:xfrm>
           <a:prstGeom prst="rect">
             <a:avLst/>
@@ -2959,7 +3035,7 @@
               <a:buNone/>
             </a:pPr>
             <a:r>
-              <a:rPr lang="en-US" sz="1500" dirty="0">
+              <a:rPr lang="en-US" sz="1600" b="1" dirty="0">
                 <a:solidFill>
                   <a:srgbClr val="0B1D3A"/>
                 </a:solidFill>
@@ -2969,13 +3045,181 @@
               </a:rPr>
               <a:t>Relationship-focused statement</a:t>
             </a:r>
-            <a:endParaRPr lang="en-US" sz="1500" dirty="0"/>
-          </a:p>
-        </p:txBody>
-      </p:sp>
-      <p:sp>
-        <p:nvSpPr>
-          <p:cNvPr id="10" name="Text 7"/>
+            <a:endParaRPr lang="en-US" sz="1600" dirty="0"/>
+          </a:p>
+        </p:txBody>
+      </p:sp>
+      <p:sp>
+        <p:nvSpPr>
+          <p:cNvPr id="13" name="Shape 11"/>
+          <p:cNvSpPr/>
+          <p:nvPr/>
+        </p:nvSpPr>
+        <p:spPr>
+          <a:xfrm>
+            <a:off x="2286000" y="4498848"/>
+            <a:ext cx="7635240" cy="530352"/>
+          </a:xfrm>
+          <a:prstGeom prst="roundRect">
+            <a:avLst/>
+          </a:prstGeom>
+          <a:solidFill>
+            <a:srgbClr val="E6F0FA"/>
+          </a:solidFill>
+          <a:ln w="12700">
+            <a:solidFill>
+              <a:srgbClr val="D4AF37"/>
+            </a:solidFill>
+            <a:prstDash val="solid"/>
+          </a:ln>
+        </p:spPr>
+      </p:sp>
+      <p:sp>
+        <p:nvSpPr>
+          <p:cNvPr id="14" name="Shape 12"/>
+          <p:cNvSpPr/>
+          <p:nvPr/>
+        </p:nvSpPr>
+        <p:spPr>
+          <a:xfrm>
+            <a:off x="2468880" y="4681728"/>
+            <a:ext cx="164592" cy="164592"/>
+          </a:xfrm>
+          <a:prstGeom prst="ellipse">
+            <a:avLst/>
+          </a:prstGeom>
+          <a:solidFill>
+            <a:srgbClr val="4D7DF3"/>
+          </a:solidFill>
+          <a:ln/>
+        </p:spPr>
+      </p:sp>
+      <p:sp>
+        <p:nvSpPr>
+          <p:cNvPr id="15" name="Text 13"/>
+          <p:cNvSpPr/>
+          <p:nvPr/>
+        </p:nvSpPr>
+        <p:spPr>
+          <a:xfrm>
+            <a:off x="2743200" y="4626864"/>
+            <a:ext cx="7086600" cy="292608"/>
+          </a:xfrm>
+          <a:prstGeom prst="rect">
+            <a:avLst/>
+          </a:prstGeom>
+          <a:noFill/>
+          <a:ln/>
+        </p:spPr>
+        <p:txBody>
+          <a:bodyPr wrap="square" rtlCol="0" anchor="ctr"/>
+          <a:lstStyle/>
+          <a:p>
+            <a:pPr indent="0" marL="0">
+              <a:buNone/>
+            </a:pPr>
+            <a:r>
+              <a:rPr lang="en-US" sz="1600" b="1" dirty="0">
+                <a:solidFill>
+                  <a:srgbClr val="0B1D3A"/>
+                </a:solidFill>
+                <a:latin typeface="Inter" pitchFamily="34" charset="0"/>
+                <a:ea typeface="Inter" pitchFamily="34" charset="-122"/>
+                <a:cs typeface="Inter" pitchFamily="34" charset="-120"/>
+              </a:rPr>
+              <a:t>Personal observations</a:t>
+            </a:r>
+            <a:endParaRPr lang="en-US" sz="1600" dirty="0"/>
+          </a:p>
+        </p:txBody>
+      </p:sp>
+      <p:sp>
+        <p:nvSpPr>
+          <p:cNvPr id="16" name="Shape 14"/>
+          <p:cNvSpPr/>
+          <p:nvPr/>
+        </p:nvSpPr>
+        <p:spPr>
+          <a:xfrm>
+            <a:off x="2286000" y="5157216"/>
+            <a:ext cx="7635240" cy="530352"/>
+          </a:xfrm>
+          <a:prstGeom prst="roundRect">
+            <a:avLst/>
+          </a:prstGeom>
+          <a:solidFill>
+            <a:srgbClr val="E6F0FA"/>
+          </a:solidFill>
+          <a:ln w="12700">
+            <a:solidFill>
+              <a:srgbClr val="D4AF37"/>
+            </a:solidFill>
+            <a:prstDash val="solid"/>
+          </a:ln>
+        </p:spPr>
+      </p:sp>
+      <p:sp>
+        <p:nvSpPr>
+          <p:cNvPr id="17" name="Shape 15"/>
+          <p:cNvSpPr/>
+          <p:nvPr/>
+        </p:nvSpPr>
+        <p:spPr>
+          <a:xfrm>
+            <a:off x="2468880" y="5340096"/>
+            <a:ext cx="164592" cy="164592"/>
+          </a:xfrm>
+          <a:prstGeom prst="ellipse">
+            <a:avLst/>
+          </a:prstGeom>
+          <a:solidFill>
+            <a:srgbClr val="4D7DF3"/>
+          </a:solidFill>
+          <a:ln/>
+        </p:spPr>
+      </p:sp>
+      <p:sp>
+        <p:nvSpPr>
+          <p:cNvPr id="18" name="Text 16"/>
+          <p:cNvSpPr/>
+          <p:nvPr/>
+        </p:nvSpPr>
+        <p:spPr>
+          <a:xfrm>
+            <a:off x="2743200" y="5285232"/>
+            <a:ext cx="7086600" cy="292608"/>
+          </a:xfrm>
+          <a:prstGeom prst="rect">
+            <a:avLst/>
+          </a:prstGeom>
+          <a:noFill/>
+          <a:ln/>
+        </p:spPr>
+        <p:txBody>
+          <a:bodyPr wrap="square" rtlCol="0" anchor="ctr"/>
+          <a:lstStyle/>
+          <a:p>
+            <a:pPr indent="0" marL="0">
+              <a:buNone/>
+            </a:pPr>
+            <a:r>
+              <a:rPr lang="en-US" sz="1600" b="1" dirty="0">
+                <a:solidFill>
+                  <a:srgbClr val="0B1D3A"/>
+                </a:solidFill>
+                <a:latin typeface="Inter" pitchFamily="34" charset="0"/>
+                <a:ea typeface="Inter" pitchFamily="34" charset="-122"/>
+                <a:cs typeface="Inter" pitchFamily="34" charset="-120"/>
+              </a:rPr>
+              <a:t>Separate witness statement</a:t>
+            </a:r>
+            <a:endParaRPr lang="en-US" sz="1600" dirty="0"/>
+          </a:p>
+        </p:txBody>
+      </p:sp>
+      <p:sp>
+        <p:nvSpPr>
+          <p:cNvPr id="19" name="Text 17"/>
           <p:cNvSpPr/>
           <p:nvPr/>
         </p:nvSpPr>
@@ -3156,7 +3400,7 @@
                 <a:ea typeface="Inter" pitchFamily="34" charset="-122"/>
                 <a:cs typeface="Inter" pitchFamily="34" charset="-120"/>
               </a:rPr>
-              <a:t>Review queue, good-faith record, and revision reasons in one workflow.</a:t>
+              <a:t>Review queue, good-faith record, and revision reasons stay organized.</a:t>
             </a:r>
             <a:endParaRPr lang="en-US" sz="1800" dirty="0"/>
           </a:p>
@@ -3170,14 +3414,187 @@
         </p:nvSpPr>
         <p:spPr>
           <a:xfrm>
-            <a:off x="146304" y="1563624"/>
-            <a:ext cx="11868912" cy="5056632"/>
+            <a:off x="8092440" y="1783080"/>
+            <a:ext cx="3611880" cy="4160520"/>
           </a:xfrm>
           <a:prstGeom prst="roundRect">
             <a:avLst/>
           </a:prstGeom>
           <a:solidFill>
             <a:srgbClr val="FFFFFF"/>
+          </a:solidFill>
+          <a:ln w="12700">
+            <a:solidFill>
+              <a:srgbClr val="E6F0FA"/>
+            </a:solidFill>
+            <a:prstDash val="solid"/>
+          </a:ln>
+        </p:spPr>
+      </p:sp>
+      <p:pic>
+        <p:nvPicPr>
+          <p:cNvPr id="7" name="Image 0" descr="C:\Users\lukoe\Downloads\asn-reports\artifacts\bfm-video-v41-2026-06-09-1322\_crops\ui-proof-faded.png">    </p:cNvPr>
+          <p:cNvPicPr>
+            <a:picLocks noChangeAspect="1"/>
+          </p:cNvPicPr>
+          <p:nvPr/>
+        </p:nvPicPr>
+        <p:blipFill>
+          <a:blip r:embed="rId1">
+            <a:alphaModFix amt="45000"/>
+          </a:blip>
+          <a:srcRect l="0" r="0" t="0" b="0"/>
+          <a:stretch/>
+        </p:blipFill>
+        <p:spPr>
+          <a:xfrm>
+            <a:off x="8183880" y="1874520"/>
+            <a:ext cx="3429000" cy="3977640"/>
+          </a:xfrm>
+          <a:prstGeom prst="rect">
+            <a:avLst/>
+          </a:prstGeom>
+        </p:spPr>
+      </p:pic>
+      <p:sp>
+        <p:nvSpPr>
+          <p:cNvPr id="8" name="Shape 5"/>
+          <p:cNvSpPr/>
+          <p:nvPr/>
+        </p:nvSpPr>
+        <p:spPr>
+          <a:xfrm>
+            <a:off x="502920" y="1783080"/>
+            <a:ext cx="7360920" cy="4160520"/>
+          </a:xfrm>
+          <a:prstGeom prst="roundRect">
+            <a:avLst/>
+          </a:prstGeom>
+          <a:solidFill>
+            <a:srgbClr val="FFFFFF"/>
+          </a:solidFill>
+          <a:ln w="19050">
+            <a:solidFill>
+              <a:srgbClr val="4D7DF3"/>
+            </a:solidFill>
+            <a:prstDash val="solid"/>
+          </a:ln>
+        </p:spPr>
+      </p:sp>
+      <p:sp>
+        <p:nvSpPr>
+          <p:cNvPr id="9" name="Shape 6"/>
+          <p:cNvSpPr/>
+          <p:nvPr/>
+        </p:nvSpPr>
+        <p:spPr>
+          <a:xfrm>
+            <a:off x="822960" y="2075688"/>
+            <a:ext cx="594360" cy="36576"/>
+          </a:xfrm>
+          <a:prstGeom prst="rect">
+            <a:avLst/>
+          </a:prstGeom>
+          <a:solidFill>
+            <a:srgbClr val="D4AF37"/>
+          </a:solidFill>
+          <a:ln/>
+        </p:spPr>
+      </p:sp>
+      <p:sp>
+        <p:nvSpPr>
+          <p:cNvPr id="10" name="Text 7"/>
+          <p:cNvSpPr/>
+          <p:nvPr/>
+        </p:nvSpPr>
+        <p:spPr>
+          <a:xfrm>
+            <a:off x="822960" y="2167128"/>
+            <a:ext cx="6720840" cy="347472"/>
+          </a:xfrm>
+          <a:prstGeom prst="rect">
+            <a:avLst/>
+          </a:prstGeom>
+          <a:noFill/>
+          <a:ln/>
+        </p:spPr>
+        <p:txBody>
+          <a:bodyPr wrap="square" rtlCol="0" anchor="ctr"/>
+          <a:lstStyle/>
+          <a:p>
+            <a:pPr indent="0" marL="0">
+              <a:buNone/>
+            </a:pPr>
+            <a:r>
+              <a:rPr lang="en-US" sz="2000" b="1" dirty="0">
+                <a:solidFill>
+                  <a:srgbClr val="0B1D3A"/>
+                </a:solidFill>
+                <a:latin typeface="Playfair Display" pitchFamily="34" charset="0"/>
+                <a:ea typeface="Playfair Display" pitchFamily="34" charset="-122"/>
+                <a:cs typeface="Playfair Display" pitchFamily="34" charset="-120"/>
+              </a:rPr>
+              <a:t>Attorney review queue</a:t>
+            </a:r>
+            <a:endParaRPr lang="en-US" sz="2000" dirty="0"/>
+          </a:p>
+        </p:txBody>
+      </p:sp>
+      <p:sp>
+        <p:nvSpPr>
+          <p:cNvPr id="11" name="Text 8"/>
+          <p:cNvSpPr/>
+          <p:nvPr/>
+        </p:nvSpPr>
+        <p:spPr>
+          <a:xfrm>
+            <a:off x="822960" y="2532888"/>
+            <a:ext cx="6720840" cy="256032"/>
+          </a:xfrm>
+          <a:prstGeom prst="rect">
+            <a:avLst/>
+          </a:prstGeom>
+          <a:noFill/>
+          <a:ln/>
+        </p:spPr>
+        <p:txBody>
+          <a:bodyPr wrap="square" rtlCol="0" anchor="ctr"/>
+          <a:lstStyle/>
+          <a:p>
+            <a:pPr indent="0" marL="0">
+              <a:buNone/>
+            </a:pPr>
+            <a:r>
+              <a:rPr lang="en-US" sz="1100" dirty="0">
+                <a:solidFill>
+                  <a:srgbClr val="334E6F"/>
+                </a:solidFill>
+                <a:latin typeface="Inter" pitchFamily="34" charset="0"/>
+                <a:ea typeface="Inter" pitchFamily="34" charset="-122"/>
+                <a:cs typeface="Inter" pitchFamily="34" charset="-120"/>
+              </a:rPr>
+              <a:t>Synthetic demo · two witnesses · same couple case</a:t>
+            </a:r>
+            <a:endParaRPr lang="en-US" sz="1100" dirty="0"/>
+          </a:p>
+        </p:txBody>
+      </p:sp>
+      <p:sp>
+        <p:nvSpPr>
+          <p:cNvPr id="12" name="Shape 9"/>
+          <p:cNvSpPr/>
+          <p:nvPr/>
+        </p:nvSpPr>
+        <p:spPr>
+          <a:xfrm>
+            <a:off x="822960" y="3017520"/>
+            <a:ext cx="6720840" cy="804672"/>
+          </a:xfrm>
+          <a:prstGeom prst="roundRect">
+            <a:avLst/>
+          </a:prstGeom>
+          <a:solidFill>
+            <a:srgbClr val="E6F0FA"/>
           </a:solidFill>
           <a:ln w="12700">
             <a:solidFill>
@@ -3187,39 +3604,551 @@
           </a:ln>
         </p:spPr>
       </p:sp>
-      <p:pic>
-        <p:nvPicPr>
-          <p:cNvPr id="7" name="Image 0" descr="C:\Users\lukoe\Downloads\asn-reports\artifacts\bfm-video-redesign-v4-2026-06-09-1247\_crops\review-hero.png">    </p:cNvPr>
-          <p:cNvPicPr>
-            <a:picLocks noChangeAspect="1"/>
-          </p:cNvPicPr>
-          <p:nvPr/>
-        </p:nvPicPr>
-        <p:blipFill>
-          <a:blip r:embed="rId1"/>
-          <a:srcRect l="0" r="0" t="0" b="0"/>
-          <a:stretch/>
-        </p:blipFill>
-        <p:spPr>
-          <a:xfrm>
-            <a:off x="182880" y="1600200"/>
-            <a:ext cx="11795760" cy="4983480"/>
-          </a:xfrm>
-          <a:prstGeom prst="rect">
-            <a:avLst/>
-          </a:prstGeom>
-        </p:spPr>
-      </p:pic>
-      <p:sp>
-        <p:nvSpPr>
-          <p:cNvPr id="8" name="Shape 5"/>
+      <p:sp>
+        <p:nvSpPr>
+          <p:cNvPr id="13" name="Text 10"/>
+          <p:cNvSpPr/>
+          <p:nvPr/>
+        </p:nvSpPr>
+        <p:spPr>
+          <a:xfrm>
+            <a:off x="1005840" y="3127248"/>
+            <a:ext cx="2926080" cy="256032"/>
+          </a:xfrm>
+          <a:prstGeom prst="rect">
+            <a:avLst/>
+          </a:prstGeom>
+          <a:noFill/>
+          <a:ln/>
+        </p:spPr>
+        <p:txBody>
+          <a:bodyPr wrap="square" rtlCol="0" anchor="ctr"/>
+          <a:lstStyle/>
+          <a:p>
+            <a:pPr indent="0" marL="0">
+              <a:buNone/>
+            </a:pPr>
+            <a:r>
+              <a:rPr lang="en-US" sz="1400" b="1" dirty="0">
+                <a:solidFill>
+                  <a:srgbClr val="0B1D3A"/>
+                </a:solidFill>
+                <a:latin typeface="Inter" pitchFamily="34" charset="0"/>
+                <a:ea typeface="Inter" pitchFamily="34" charset="-122"/>
+                <a:cs typeface="Inter" pitchFamily="34" charset="-120"/>
+              </a:rPr>
+              <a:t>Clara Johnson</a:t>
+            </a:r>
+            <a:endParaRPr lang="en-US" sz="1400" dirty="0"/>
+          </a:p>
+        </p:txBody>
+      </p:sp>
+      <p:sp>
+        <p:nvSpPr>
+          <p:cNvPr id="14" name="Text 11"/>
+          <p:cNvSpPr/>
+          <p:nvPr/>
+        </p:nvSpPr>
+        <p:spPr>
+          <a:xfrm>
+            <a:off x="1005840" y="3401568"/>
+            <a:ext cx="6446520" cy="256032"/>
+          </a:xfrm>
+          <a:prstGeom prst="rect">
+            <a:avLst/>
+          </a:prstGeom>
+          <a:noFill/>
+          <a:ln/>
+        </p:spPr>
+        <p:txBody>
+          <a:bodyPr wrap="square" rtlCol="0" anchor="ctr"/>
+          <a:lstStyle/>
+          <a:p>
+            <a:pPr indent="0" marL="0">
+              <a:buNone/>
+            </a:pPr>
+            <a:r>
+              <a:rPr lang="en-US" sz="1200" dirty="0">
+                <a:solidFill>
+                  <a:srgbClr val="334E6F"/>
+                </a:solidFill>
+                <a:latin typeface="Inter" pitchFamily="34" charset="0"/>
+                <a:ea typeface="Inter" pitchFamily="34" charset="-122"/>
+                <a:cs typeface="Inter" pitchFamily="34" charset="-120"/>
+              </a:rPr>
+              <a:t>Relationship statement · Needs review</a:t>
+            </a:r>
+            <a:endParaRPr lang="en-US" sz="1200" dirty="0"/>
+          </a:p>
+        </p:txBody>
+      </p:sp>
+      <p:sp>
+        <p:nvSpPr>
+          <p:cNvPr id="15" name="Shape 12"/>
+          <p:cNvSpPr/>
+          <p:nvPr/>
+        </p:nvSpPr>
+        <p:spPr>
+          <a:xfrm>
+            <a:off x="6629400" y="3273552"/>
+            <a:ext cx="868680" cy="292608"/>
+          </a:xfrm>
+          <a:prstGeom prst="roundRect">
+            <a:avLst/>
+          </a:prstGeom>
+          <a:solidFill>
+            <a:srgbClr val="D97706"/>
+          </a:solidFill>
+          <a:ln/>
+        </p:spPr>
+      </p:sp>
+      <p:sp>
+        <p:nvSpPr>
+          <p:cNvPr id="16" name="Text 13"/>
+          <p:cNvSpPr/>
+          <p:nvPr/>
+        </p:nvSpPr>
+        <p:spPr>
+          <a:xfrm>
+            <a:off x="6629400" y="3328416"/>
+            <a:ext cx="868680" cy="201168"/>
+          </a:xfrm>
+          <a:prstGeom prst="rect">
+            <a:avLst/>
+          </a:prstGeom>
+          <a:noFill/>
+          <a:ln/>
+        </p:spPr>
+        <p:txBody>
+          <a:bodyPr wrap="square" rtlCol="0" anchor="ctr"/>
+          <a:lstStyle/>
+          <a:p>
+            <a:pPr algn="ctr" indent="0" marL="0">
+              <a:buNone/>
+            </a:pPr>
+            <a:r>
+              <a:rPr lang="en-US" sz="1000" b="1" dirty="0">
+                <a:solidFill>
+                  <a:srgbClr val="FFFFFF"/>
+                </a:solidFill>
+                <a:latin typeface="Inter" pitchFamily="34" charset="0"/>
+                <a:ea typeface="Inter" pitchFamily="34" charset="-122"/>
+                <a:cs typeface="Inter" pitchFamily="34" charset="-120"/>
+              </a:rPr>
+              <a:t>Review</a:t>
+            </a:r>
+            <a:endParaRPr lang="en-US" sz="1000" dirty="0"/>
+          </a:p>
+        </p:txBody>
+      </p:sp>
+      <p:sp>
+        <p:nvSpPr>
+          <p:cNvPr id="17" name="Shape 14"/>
+          <p:cNvSpPr/>
+          <p:nvPr/>
+        </p:nvSpPr>
+        <p:spPr>
+          <a:xfrm>
+            <a:off x="822960" y="3977640"/>
+            <a:ext cx="6720840" cy="804672"/>
+          </a:xfrm>
+          <a:prstGeom prst="roundRect">
+            <a:avLst/>
+          </a:prstGeom>
+          <a:solidFill>
+            <a:srgbClr val="E6F0FA"/>
+          </a:solidFill>
+          <a:ln w="12700">
+            <a:solidFill>
+              <a:srgbClr val="4D7DF3"/>
+            </a:solidFill>
+            <a:prstDash val="solid"/>
+          </a:ln>
+        </p:spPr>
+      </p:sp>
+      <p:sp>
+        <p:nvSpPr>
+          <p:cNvPr id="18" name="Text 15"/>
+          <p:cNvSpPr/>
+          <p:nvPr/>
+        </p:nvSpPr>
+        <p:spPr>
+          <a:xfrm>
+            <a:off x="1005840" y="4087368"/>
+            <a:ext cx="2926080" cy="256032"/>
+          </a:xfrm>
+          <a:prstGeom prst="rect">
+            <a:avLst/>
+          </a:prstGeom>
+          <a:noFill/>
+          <a:ln/>
+        </p:spPr>
+        <p:txBody>
+          <a:bodyPr wrap="square" rtlCol="0" anchor="ctr"/>
+          <a:lstStyle/>
+          <a:p>
+            <a:pPr indent="0" marL="0">
+              <a:buNone/>
+            </a:pPr>
+            <a:r>
+              <a:rPr lang="en-US" sz="1400" b="1" dirty="0">
+                <a:solidFill>
+                  <a:srgbClr val="0B1D3A"/>
+                </a:solidFill>
+                <a:latin typeface="Inter" pitchFamily="34" charset="0"/>
+                <a:ea typeface="Inter" pitchFamily="34" charset="-122"/>
+                <a:cs typeface="Inter" pitchFamily="34" charset="-120"/>
+              </a:rPr>
+              <a:t>Michael Turner</a:t>
+            </a:r>
+            <a:endParaRPr lang="en-US" sz="1400" dirty="0"/>
+          </a:p>
+        </p:txBody>
+      </p:sp>
+      <p:sp>
+        <p:nvSpPr>
+          <p:cNvPr id="19" name="Text 16"/>
+          <p:cNvSpPr/>
+          <p:nvPr/>
+        </p:nvSpPr>
+        <p:spPr>
+          <a:xfrm>
+            <a:off x="1005840" y="4361688"/>
+            <a:ext cx="6446520" cy="256032"/>
+          </a:xfrm>
+          <a:prstGeom prst="rect">
+            <a:avLst/>
+          </a:prstGeom>
+          <a:noFill/>
+          <a:ln/>
+        </p:spPr>
+        <p:txBody>
+          <a:bodyPr wrap="square" rtlCol="0" anchor="ctr"/>
+          <a:lstStyle/>
+          <a:p>
+            <a:pPr indent="0" marL="0">
+              <a:buNone/>
+            </a:pPr>
+            <a:r>
+              <a:rPr lang="en-US" sz="1200" dirty="0">
+                <a:solidFill>
+                  <a:srgbClr val="334E6F"/>
+                </a:solidFill>
+                <a:latin typeface="Inter" pitchFamily="34" charset="0"/>
+                <a:ea typeface="Inter" pitchFamily="34" charset="-122"/>
+                <a:cs typeface="Inter" pitchFamily="34" charset="-120"/>
+              </a:rPr>
+              <a:t>Relationship statement · Needs review</a:t>
+            </a:r>
+            <a:endParaRPr lang="en-US" sz="1200" dirty="0"/>
+          </a:p>
+        </p:txBody>
+      </p:sp>
+      <p:sp>
+        <p:nvSpPr>
+          <p:cNvPr id="20" name="Shape 17"/>
+          <p:cNvSpPr/>
+          <p:nvPr/>
+        </p:nvSpPr>
+        <p:spPr>
+          <a:xfrm>
+            <a:off x="6629400" y="4233672"/>
+            <a:ext cx="868680" cy="292608"/>
+          </a:xfrm>
+          <a:prstGeom prst="roundRect">
+            <a:avLst/>
+          </a:prstGeom>
+          <a:solidFill>
+            <a:srgbClr val="D97706"/>
+          </a:solidFill>
+          <a:ln/>
+        </p:spPr>
+      </p:sp>
+      <p:sp>
+        <p:nvSpPr>
+          <p:cNvPr id="21" name="Text 18"/>
+          <p:cNvSpPr/>
+          <p:nvPr/>
+        </p:nvSpPr>
+        <p:spPr>
+          <a:xfrm>
+            <a:off x="6629400" y="4288536"/>
+            <a:ext cx="868680" cy="201168"/>
+          </a:xfrm>
+          <a:prstGeom prst="rect">
+            <a:avLst/>
+          </a:prstGeom>
+          <a:noFill/>
+          <a:ln/>
+        </p:spPr>
+        <p:txBody>
+          <a:bodyPr wrap="square" rtlCol="0" anchor="ctr"/>
+          <a:lstStyle/>
+          <a:p>
+            <a:pPr algn="ctr" indent="0" marL="0">
+              <a:buNone/>
+            </a:pPr>
+            <a:r>
+              <a:rPr lang="en-US" sz="1000" b="1" dirty="0">
+                <a:solidFill>
+                  <a:srgbClr val="FFFFFF"/>
+                </a:solidFill>
+                <a:latin typeface="Inter" pitchFamily="34" charset="0"/>
+                <a:ea typeface="Inter" pitchFamily="34" charset="-122"/>
+                <a:cs typeface="Inter" pitchFamily="34" charset="-120"/>
+              </a:rPr>
+              <a:t>Review</a:t>
+            </a:r>
+            <a:endParaRPr lang="en-US" sz="1000" dirty="0"/>
+          </a:p>
+        </p:txBody>
+      </p:sp>
+      <p:sp>
+        <p:nvSpPr>
+          <p:cNvPr id="22" name="Shape 19"/>
+          <p:cNvSpPr/>
+          <p:nvPr/>
+        </p:nvSpPr>
+        <p:spPr>
+          <a:xfrm>
+            <a:off x="822960" y="5285232"/>
+            <a:ext cx="868680" cy="347472"/>
+          </a:xfrm>
+          <a:prstGeom prst="roundRect">
+            <a:avLst/>
+          </a:prstGeom>
+          <a:solidFill>
+            <a:srgbClr val="4D7DF3"/>
+          </a:solidFill>
+          <a:ln/>
+        </p:spPr>
+      </p:sp>
+      <p:sp>
+        <p:nvSpPr>
+          <p:cNvPr id="23" name="Text 20"/>
+          <p:cNvSpPr/>
+          <p:nvPr/>
+        </p:nvSpPr>
+        <p:spPr>
+          <a:xfrm>
+            <a:off x="822960" y="5358384"/>
+            <a:ext cx="868680" cy="219456"/>
+          </a:xfrm>
+          <a:prstGeom prst="rect">
+            <a:avLst/>
+          </a:prstGeom>
+          <a:noFill/>
+          <a:ln/>
+        </p:spPr>
+        <p:txBody>
+          <a:bodyPr wrap="square" rtlCol="0" anchor="ctr"/>
+          <a:lstStyle/>
+          <a:p>
+            <a:pPr algn="ctr" indent="0" marL="0">
+              <a:buNone/>
+            </a:pPr>
+            <a:r>
+              <a:rPr lang="en-US" sz="1100" b="1" dirty="0">
+                <a:solidFill>
+                  <a:srgbClr val="FFFFFF"/>
+                </a:solidFill>
+                <a:latin typeface="Inter" pitchFamily="34" charset="0"/>
+                <a:ea typeface="Inter" pitchFamily="34" charset="-122"/>
+                <a:cs typeface="Inter" pitchFamily="34" charset="-120"/>
+              </a:rPr>
+              <a:t>Review</a:t>
+            </a:r>
+            <a:endParaRPr lang="en-US" sz="1100" dirty="0"/>
+          </a:p>
+        </p:txBody>
+      </p:sp>
+      <p:sp>
+        <p:nvSpPr>
+          <p:cNvPr id="24" name="Shape 21"/>
+          <p:cNvSpPr/>
+          <p:nvPr/>
+        </p:nvSpPr>
+        <p:spPr>
+          <a:xfrm>
+            <a:off x="1801368" y="5285232"/>
+            <a:ext cx="1417320" cy="347472"/>
+          </a:xfrm>
+          <a:prstGeom prst="roundRect">
+            <a:avLst/>
+          </a:prstGeom>
+          <a:solidFill>
+            <a:srgbClr val="0B1D3A"/>
+          </a:solidFill>
+          <a:ln/>
+        </p:spPr>
+      </p:sp>
+      <p:sp>
+        <p:nvSpPr>
+          <p:cNvPr id="25" name="Text 22"/>
+          <p:cNvSpPr/>
+          <p:nvPr/>
+        </p:nvSpPr>
+        <p:spPr>
+          <a:xfrm>
+            <a:off x="1801368" y="5358384"/>
+            <a:ext cx="1417320" cy="219456"/>
+          </a:xfrm>
+          <a:prstGeom prst="rect">
+            <a:avLst/>
+          </a:prstGeom>
+          <a:noFill/>
+          <a:ln/>
+        </p:spPr>
+        <p:txBody>
+          <a:bodyPr wrap="square" rtlCol="0" anchor="ctr"/>
+          <a:lstStyle/>
+          <a:p>
+            <a:pPr algn="ctr" indent="0" marL="0">
+              <a:buNone/>
+            </a:pPr>
+            <a:r>
+              <a:rPr lang="en-US" sz="1100" b="1" dirty="0">
+                <a:solidFill>
+                  <a:srgbClr val="FFFFFF"/>
+                </a:solidFill>
+                <a:latin typeface="Inter" pitchFamily="34" charset="0"/>
+                <a:ea typeface="Inter" pitchFamily="34" charset="-122"/>
+                <a:cs typeface="Inter" pitchFamily="34" charset="-120"/>
+              </a:rPr>
+              <a:t>Request revision</a:t>
+            </a:r>
+            <a:endParaRPr lang="en-US" sz="1100" dirty="0"/>
+          </a:p>
+        </p:txBody>
+      </p:sp>
+      <p:sp>
+        <p:nvSpPr>
+          <p:cNvPr id="26" name="Shape 23"/>
+          <p:cNvSpPr/>
+          <p:nvPr/>
+        </p:nvSpPr>
+        <p:spPr>
+          <a:xfrm>
+            <a:off x="3328416" y="5285232"/>
+            <a:ext cx="960120" cy="347472"/>
+          </a:xfrm>
+          <a:prstGeom prst="roundRect">
+            <a:avLst/>
+          </a:prstGeom>
+          <a:solidFill>
+            <a:srgbClr val="E6F0FA"/>
+          </a:solidFill>
+          <a:ln/>
+        </p:spPr>
+      </p:sp>
+      <p:sp>
+        <p:nvSpPr>
+          <p:cNvPr id="27" name="Text 24"/>
+          <p:cNvSpPr/>
+          <p:nvPr/>
+        </p:nvSpPr>
+        <p:spPr>
+          <a:xfrm>
+            <a:off x="3328416" y="5358384"/>
+            <a:ext cx="960120" cy="219456"/>
+          </a:xfrm>
+          <a:prstGeom prst="rect">
+            <a:avLst/>
+          </a:prstGeom>
+          <a:noFill/>
+          <a:ln/>
+        </p:spPr>
+        <p:txBody>
+          <a:bodyPr wrap="square" rtlCol="0" anchor="ctr"/>
+          <a:lstStyle/>
+          <a:p>
+            <a:pPr algn="ctr" indent="0" marL="0">
+              <a:buNone/>
+            </a:pPr>
+            <a:r>
+              <a:rPr lang="en-US" sz="1100" b="1" dirty="0">
+                <a:solidFill>
+                  <a:srgbClr val="0B1D3A"/>
+                </a:solidFill>
+                <a:latin typeface="Inter" pitchFamily="34" charset="0"/>
+                <a:ea typeface="Inter" pitchFamily="34" charset="-122"/>
+                <a:cs typeface="Inter" pitchFamily="34" charset="-120"/>
+              </a:rPr>
+              <a:t>Timeline</a:t>
+            </a:r>
+            <a:endParaRPr lang="en-US" sz="1100" dirty="0"/>
+          </a:p>
+        </p:txBody>
+      </p:sp>
+      <p:sp>
+        <p:nvSpPr>
+          <p:cNvPr id="28" name="Shape 25"/>
+          <p:cNvSpPr/>
+          <p:nvPr/>
+        </p:nvSpPr>
+        <p:spPr>
+          <a:xfrm>
+            <a:off x="4398264" y="5285232"/>
+            <a:ext cx="868680" cy="347472"/>
+          </a:xfrm>
+          <a:prstGeom prst="roundRect">
+            <a:avLst/>
+          </a:prstGeom>
+          <a:solidFill>
+            <a:srgbClr val="16A34A"/>
+          </a:solidFill>
+          <a:ln/>
+        </p:spPr>
+      </p:sp>
+      <p:sp>
+        <p:nvSpPr>
+          <p:cNvPr id="29" name="Text 26"/>
+          <p:cNvSpPr/>
+          <p:nvPr/>
+        </p:nvSpPr>
+        <p:spPr>
+          <a:xfrm>
+            <a:off x="4398264" y="5358384"/>
+            <a:ext cx="868680" cy="219456"/>
+          </a:xfrm>
+          <a:prstGeom prst="rect">
+            <a:avLst/>
+          </a:prstGeom>
+          <a:noFill/>
+          <a:ln/>
+        </p:spPr>
+        <p:txBody>
+          <a:bodyPr wrap="square" rtlCol="0" anchor="ctr"/>
+          <a:lstStyle/>
+          <a:p>
+            <a:pPr algn="ctr" indent="0" marL="0">
+              <a:buNone/>
+            </a:pPr>
+            <a:r>
+              <a:rPr lang="en-US" sz="1100" b="1" dirty="0">
+                <a:solidFill>
+                  <a:srgbClr val="FFFFFF"/>
+                </a:solidFill>
+                <a:latin typeface="Inter" pitchFamily="34" charset="0"/>
+                <a:ea typeface="Inter" pitchFamily="34" charset="-122"/>
+                <a:cs typeface="Inter" pitchFamily="34" charset="-120"/>
+              </a:rPr>
+              <a:t>Approve</a:t>
+            </a:r>
+            <a:endParaRPr lang="en-US" sz="1100" dirty="0"/>
+          </a:p>
+        </p:txBody>
+      </p:sp>
+      <p:sp>
+        <p:nvSpPr>
+          <p:cNvPr id="30" name="Shape 27"/>
           <p:cNvSpPr/>
           <p:nvPr/>
         </p:nvSpPr>
         <p:spPr>
           <a:xfrm>
             <a:off x="502920" y="5504688"/>
-            <a:ext cx="4572000" cy="457200"/>
+            <a:ext cx="4937760" cy="457200"/>
           </a:xfrm>
           <a:prstGeom prst="roundRect">
             <a:avLst/>
@@ -3237,14 +4166,14 @@
       </p:sp>
       <p:sp>
         <p:nvSpPr>
-          <p:cNvPr id="9" name="Text 6"/>
+          <p:cNvPr id="31" name="Text 28"/>
           <p:cNvSpPr/>
           <p:nvPr/>
         </p:nvSpPr>
         <p:spPr>
           <a:xfrm>
             <a:off x="612648" y="5596128"/>
-            <a:ext cx="4352544" cy="292608"/>
+            <a:ext cx="4709160" cy="292608"/>
           </a:xfrm>
           <a:prstGeom prst="rect">
             <a:avLst/>
@@ -3276,7 +4205,7 @@
       </p:sp>
       <p:sp>
         <p:nvSpPr>
-          <p:cNvPr id="10" name="Text 7"/>
+          <p:cNvPr id="32" name="Text 29"/>
           <p:cNvSpPr/>
           <p:nvPr/>
         </p:nvSpPr>

</xml_diff>